<commit_message>
Add new tenure hero analysis files and update campaign plan documentation
- Introduced a new PDF for the disposable tenure hero thread, enhancing the documentation for ongoing analysis.
- Updated the `TENURE_HERO_Campaign_Plan.md` to clarify the treatment of censored data in quantile ranks, improving the understanding of the campaign's methodology.
- Added new metadata and visual outputs for performance metrics, including multiple new JSON and PNG files, supporting detailed analysis and documentation.
- Created new CSV and LPM files for tenure hero analysis, expanding the analytical capabilities of the tenure sandbox.

These updates strengthen the framework for tenure evaluations, providing clearer guidance and enhanced capabilities for performance analysis.
</commit_message>
<xml_diff>
--- a/3-Master_Plan/re_entry/HEROs_and_PASSes/tenure_sandbox/basic_data_plots/TENURE_BDP_slides_AUTO.pptx
+++ b/3-Master_Plan/re_entry/HEROs_and_PASSes/tenure_sandbox/basic_data_plots/TENURE_BDP_slides_AUTO.pptx
@@ -10,6 +10,10 @@
     <p:sldId id="258" r:id="rId9"/>
     <p:sldId id="259" r:id="rId10"/>
     <p:sldId id="260" r:id="rId11"/>
+    <p:sldId id="261" r:id="rId12"/>
+    <p:sldId id="262" r:id="rId13"/>
+    <p:sldId id="263" r:id="rId14"/>
+    <p:sldId id="264" r:id="rId15"/>
   </p:sldIdLst>
   <p:sldSz cx="12191695" cy="6858000" type="screen4x3"/>
   <p:notesSz cx="6858000" cy="9144000"/>
@@ -3420,7 +3424,7 @@
               <a:defRPr sz="1000"/>
             </a:pPr>
             <a:r>
-              <a:t>uni-years=283 · asst-years=2,396 · max coverage=245 · H_sort=0.173</a:t>
+              <a:t>uni-year pools=283 · asst-years=2,396 · max coverage=245 · H_sort=0.173</a:t>
             </a:r>
           </a:p>
         </p:txBody>
@@ -3469,7 +3473,7 @@
               <a:defRPr b="1" sz="2000"/>
             </a:pPr>
             <a:r>
-              <a:t>Slide 2 — poolq_LOO distribution (HERO grain)</a:t>
+              <a:t>Slide 2 — Uni-year peer pool interval overlap (pubs &gt; 0)</a:t>
             </a:r>
           </a:p>
           <a:p>
@@ -3477,7 +3481,7 @@
               <a:defRPr sz="1200" i="1"/>
             </a:pPr>
             <a:r>
-              <a:t>Person-level mean · N≈796 matches Q16/Q20 HERO</a:t>
+              <a:t>Sensitivity — intensive margin only · compare to prior slide</a:t>
             </a:r>
           </a:p>
         </p:txBody>
@@ -3511,7 +3515,7 @@
               <a:defRPr sz="1100"/>
             </a:pPr>
             <a:r>
-              <a:t>• Same collapse as tenure_pass_a_hero: mean poolq_loo_mean over assistant years.</a:t>
+              <a:t>• Same pool unit; assistant-years with pubs_year = 0 dropped before z and intervals.</a:t>
             </a:r>
           </a:p>
           <a:p>
@@ -3522,14 +3526,25 @@
               <a:defRPr sz="1100"/>
             </a:pPr>
             <a:r>
-              <a:t>• Right-skew drives equal-width bin sparsity at high LOO.</a:t>
+              <a:t>• z within year recomputed on pubs &gt; 0 rows only (not identical to full-panel z).</a:t>
+            </a:r>
+          </a:p>
+          <a:p>
+            <a:pPr>
+              <a:spcAft>
+                <a:spcPts val="200"/>
+              </a:spcAft>
+              <a:defRPr sz="1100"/>
+            </a:pPr>
+            <a:r>
+              <a:t>• Compare H_sort and coverage to full-panel slide — zeros inflate overlap mass at bottom.</a:t>
             </a:r>
           </a:p>
         </p:txBody>
       </p:sp>
       <p:pic>
         <p:nvPicPr>
-          <p:cNvPr id="4" name="Picture 3" descr="TENURE_poolq_loo_distribution_infHM.png"/>
+          <p:cNvPr id="4" name="Picture 3" descr="TENURE_pool_interval_overlap_infHM_pubs_gt0.png"/>
           <p:cNvPicPr>
             <a:picLocks noChangeAspect="1"/>
           </p:cNvPicPr>
@@ -3543,8 +3558,8 @@
         </p:blipFill>
         <p:spPr>
           <a:xfrm>
-            <a:off x="2971490" y="1545336"/>
-            <a:ext cx="6248715" cy="3877056"/>
+            <a:off x="3588034" y="1545336"/>
+            <a:ext cx="5015626" cy="3877056"/>
           </a:xfrm>
           <a:prstGeom prst="rect">
             <a:avLst/>
@@ -3579,7 +3594,7 @@
               </a:defRPr>
             </a:pPr>
             <a:r>
-              <a:t>python tenure/scripts/tenure_basic_plots.py --only poolq_loo</a:t>
+              <a:t>python tenure/scripts/tenure_basic_plots.py --only overlap_gt0</a:t>
             </a:r>
           </a:p>
         </p:txBody>
@@ -3610,7 +3625,7 @@
               <a:defRPr sz="1000"/>
             </a:pPr>
             <a:r>
-              <a:t>n=796 · median=3.35 · mean=4.24 · sd=3.16</a:t>
+              <a:t>uni-year pools=263 · asst-years=1,544 · max coverage=208 · H_sort=0.204</a:t>
             </a:r>
           </a:p>
         </p:txBody>
@@ -3659,7 +3674,7 @@
               <a:defRPr b="1" sz="2000"/>
             </a:pPr>
             <a:r>
-              <a:t>Slide 3 — Own pubs_year distribution</a:t>
+              <a:t>Slide 3 — poolq_LOO distribution (HERO grain)</a:t>
             </a:r>
           </a:p>
           <a:p>
@@ -3667,7 +3682,7 @@
               <a:defRPr sz="1200" i="1"/>
             </a:pPr>
             <a:r>
-              <a:t>Assistant person-years · inference panel</a:t>
+              <a:t>Person-level mean · N≈796 matches Q16/Q20 HERO</a:t>
             </a:r>
           </a:p>
         </p:txBody>
@@ -3701,7 +3716,7 @@
               <a:defRPr sz="1100"/>
             </a:pPr>
             <a:r>
-              <a:t>• Own annual publications (OpenAlex) on assistant rows in inference slice.</a:t>
+              <a:t>• Same collapse as tenure_pass_a_hero: mean poolq_loo_mean over assistant years.</a:t>
             </a:r>
           </a:p>
           <a:p>
@@ -3712,14 +3727,14 @@
               <a:defRPr sz="1100"/>
             </a:pPr>
             <a:r>
-              <a:t>• Companion to poolq_LOO — separates individual output from peer context.</a:t>
+              <a:t>• Right-skew drives equal-width bin sparsity at high LOO.</a:t>
             </a:r>
           </a:p>
         </p:txBody>
       </p:sp>
       <p:pic>
         <p:nvPicPr>
-          <p:cNvPr id="4" name="Picture 3" descr="TENURE_pubs_year_distribution_infHM.png"/>
+          <p:cNvPr id="4" name="Picture 3" descr="TENURE_poolq_loo_distribution_infHM.png"/>
           <p:cNvPicPr>
             <a:picLocks noChangeAspect="1"/>
           </p:cNvPicPr>
@@ -3769,7 +3784,7 @@
               </a:defRPr>
             </a:pPr>
             <a:r>
-              <a:t>python tenure/scripts/tenure_basic_plots.py --only pubs_year</a:t>
+              <a:t>python tenure/scripts/tenure_basic_plots.py --only poolq_loo</a:t>
             </a:r>
           </a:p>
         </p:txBody>
@@ -3800,7 +3815,7 @@
               <a:defRPr sz="1000"/>
             </a:pPr>
             <a:r>
-              <a:t>n=2,396 · median=3.00 · mean=6.27 · sd=11.66</a:t>
+              <a:t>n=796 · median=3.35 · mean=4.24 · sd=3.16</a:t>
             </a:r>
           </a:p>
         </p:txBody>
@@ -3849,7 +3864,208 @@
               <a:defRPr b="1" sz="2000"/>
             </a:pPr>
             <a:r>
-              <a:t>Slide 4 — LOO peer pool size distribution</a:t>
+              <a:t>Slide 4 — Own pubs_year distribution</a:t>
+            </a:r>
+          </a:p>
+          <a:p>
+            <a:pPr>
+              <a:defRPr sz="1200" i="1"/>
+            </a:pPr>
+            <a:r>
+              <a:t>Unconditional + inset (pubs &gt; 0) · inference panel</a:t>
+            </a:r>
+          </a:p>
+        </p:txBody>
+      </p:sp>
+      <p:sp>
+        <p:nvSpPr>
+          <p:cNvPr id="3" name="TextBox 2"/>
+          <p:cNvSpPr txBox="1"/>
+          <p:nvPr/>
+        </p:nvSpPr>
+        <p:spPr>
+          <a:xfrm>
+            <a:off x="411480" y="777240"/>
+            <a:ext cx="11368735" cy="713232"/>
+          </a:xfrm>
+          <a:prstGeom prst="rect">
+            <a:avLst/>
+          </a:prstGeom>
+          <a:noFill/>
+        </p:spPr>
+        <p:txBody>
+          <a:bodyPr wrap="square">
+            <a:spAutoFit/>
+          </a:bodyPr>
+          <a:lstStyle/>
+          <a:p>
+            <a:pPr>
+              <a:spcAft>
+                <a:spcPts val="200"/>
+              </a:spcAft>
+              <a:defRPr sz="1100"/>
+            </a:pPr>
+            <a:r>
+              <a:t>• Main: all assistant-years (36% zero pub years in OpenAlex count).</a:t>
+            </a:r>
+          </a:p>
+          <a:p>
+            <a:pPr>
+              <a:spcAft>
+                <a:spcPts val="200"/>
+              </a:spcAft>
+              <a:defRPr sz="1100"/>
+            </a:pPr>
+            <a:r>
+              <a:t>• Inset: intensive margin — shape among those with ≥1 pub (N≈1,544).</a:t>
+            </a:r>
+          </a:p>
+          <a:p>
+            <a:pPr>
+              <a:spcAft>
+                <a:spcPts val="200"/>
+              </a:spcAft>
+              <a:defRPr sz="1100"/>
+            </a:pPr>
+            <a:r>
+              <a:t>• Main x-axis capped near p99; tail max=237 noted in legend box.</a:t>
+            </a:r>
+          </a:p>
+        </p:txBody>
+      </p:sp>
+      <p:pic>
+        <p:nvPicPr>
+          <p:cNvPr id="4" name="Picture 3" descr="TENURE_pubs_year_distribution_infHM.png"/>
+          <p:cNvPicPr>
+            <a:picLocks noChangeAspect="1"/>
+          </p:cNvPicPr>
+          <p:nvPr/>
+        </p:nvPicPr>
+        <p:blipFill>
+          <a:blip r:embed="rId2"/>
+          <a:stretch>
+            <a:fillRect/>
+          </a:stretch>
+        </p:blipFill>
+        <p:spPr>
+          <a:xfrm>
+            <a:off x="2932854" y="1545336"/>
+            <a:ext cx="6325987" cy="3877056"/>
+          </a:xfrm>
+          <a:prstGeom prst="rect">
+            <a:avLst/>
+          </a:prstGeom>
+        </p:spPr>
+      </p:pic>
+      <p:sp>
+        <p:nvSpPr>
+          <p:cNvPr id="5" name="TextBox 4"/>
+          <p:cNvSpPr txBox="1"/>
+          <p:nvPr/>
+        </p:nvSpPr>
+        <p:spPr>
+          <a:xfrm>
+            <a:off x="411480" y="5495544"/>
+            <a:ext cx="11368735" cy="502920"/>
+          </a:xfrm>
+          <a:prstGeom prst="rect">
+            <a:avLst/>
+          </a:prstGeom>
+          <a:noFill/>
+        </p:spPr>
+        <p:txBody>
+          <a:bodyPr wrap="square" anchor="t">
+            <a:spAutoFit/>
+          </a:bodyPr>
+          <a:lstStyle/>
+          <a:p>
+            <a:pPr algn="l">
+              <a:defRPr sz="800">
+                <a:latin typeface="Menlo"/>
+              </a:defRPr>
+            </a:pPr>
+            <a:r>
+              <a:t>python tenure/scripts/tenure_basic_plots.py --only pubs_year</a:t>
+            </a:r>
+          </a:p>
+        </p:txBody>
+      </p:sp>
+      <p:sp>
+        <p:nvSpPr>
+          <p:cNvPr id="6" name="TextBox 5"/>
+          <p:cNvSpPr txBox="1"/>
+          <p:nvPr/>
+        </p:nvSpPr>
+        <p:spPr>
+          <a:xfrm>
+            <a:off x="411480" y="6035040"/>
+            <a:ext cx="11368735" cy="384048"/>
+          </a:xfrm>
+          <a:prstGeom prst="rect">
+            <a:avLst/>
+          </a:prstGeom>
+          <a:noFill/>
+        </p:spPr>
+        <p:txBody>
+          <a:bodyPr wrap="square">
+            <a:spAutoFit/>
+          </a:bodyPr>
+          <a:lstStyle/>
+          <a:p>
+            <a:pPr>
+              <a:defRPr sz="1000"/>
+            </a:pPr>
+            <a:r>
+              <a:t>all n=2,396 (36% zero) · inset n=1,544 · med=7.0 · mean=9.7</a:t>
+            </a:r>
+          </a:p>
+        </p:txBody>
+      </p:sp>
+    </p:spTree>
+  </p:cSld>
+  <p:clrMapOvr>
+    <a:masterClrMapping/>
+  </p:clrMapOvr>
+</p:sld>
+</file>
+
+<file path=ppt/slides/slide6.xml><?xml version="1.0" encoding="utf-8"?>
+<p:sld xmlns:a="http://schemas.openxmlformats.org/drawingml/2006/main" xmlns:p="http://schemas.openxmlformats.org/presentationml/2006/main" xmlns:r="http://schemas.openxmlformats.org/officeDocument/2006/relationships">
+  <p:cSld>
+    <p:spTree>
+      <p:nvGrpSpPr>
+        <p:cNvPr id="1" name=""/>
+        <p:cNvGrpSpPr/>
+        <p:nvPr/>
+      </p:nvGrpSpPr>
+      <p:grpSpPr/>
+      <p:sp>
+        <p:nvSpPr>
+          <p:cNvPr id="2" name="TextBox 1"/>
+          <p:cNvSpPr txBox="1"/>
+          <p:nvPr/>
+        </p:nvSpPr>
+        <p:spPr>
+          <a:xfrm>
+            <a:off x="411480" y="201168"/>
+            <a:ext cx="11368735" cy="502920"/>
+          </a:xfrm>
+          <a:prstGeom prst="rect">
+            <a:avLst/>
+          </a:prstGeom>
+          <a:noFill/>
+        </p:spPr>
+        <p:txBody>
+          <a:bodyPr wrap="square">
+            <a:spAutoFit/>
+          </a:bodyPr>
+          <a:lstStyle/>
+          <a:p>
+            <a:pPr>
+              <a:defRPr b="1" sz="2000"/>
+            </a:pPr>
+            <a:r>
+              <a:t>Slide 5 — LOO peer pool size distribution</a:t>
             </a:r>
           </a:p>
           <a:p>
@@ -3991,6 +4207,609 @@
             </a:pPr>
             <a:r>
               <a:t>n=2,396 · median=15.00 · mean=17.22 · sd=10.32</a:t>
+            </a:r>
+          </a:p>
+        </p:txBody>
+      </p:sp>
+    </p:spTree>
+  </p:cSld>
+  <p:clrMapOvr>
+    <a:masterClrMapping/>
+  </p:clrMapOvr>
+</p:sld>
+</file>
+
+<file path=ppt/slides/slide7.xml><?xml version="1.0" encoding="utf-8"?>
+<p:sld xmlns:a="http://schemas.openxmlformats.org/drawingml/2006/main" xmlns:p="http://schemas.openxmlformats.org/presentationml/2006/main" xmlns:r="http://schemas.openxmlformats.org/officeDocument/2006/relationships">
+  <p:cSld>
+    <p:spTree>
+      <p:nvGrpSpPr>
+        <p:cNvPr id="1" name=""/>
+        <p:cNvGrpSpPr/>
+        <p:nvPr/>
+      </p:nvGrpSpPr>
+      <p:grpSpPr/>
+      <p:sp>
+        <p:nvSpPr>
+          <p:cNvPr id="2" name="TextBox 1"/>
+          <p:cNvSpPr txBox="1"/>
+          <p:nvPr/>
+        </p:nvSpPr>
+        <p:spPr>
+          <a:xfrm>
+            <a:off x="411480" y="201168"/>
+            <a:ext cx="11368735" cy="502920"/>
+          </a:xfrm>
+          <a:prstGeom prst="rect">
+            <a:avLst/>
+          </a:prstGeom>
+          <a:noFill/>
+        </p:spPr>
+        <p:txBody>
+          <a:bodyPr wrap="square">
+            <a:spAutoFit/>
+          </a:bodyPr>
+          <a:lstStyle/>
+          <a:p>
+            <a:pPr>
+              <a:defRPr b="1" sz="2000"/>
+            </a:pPr>
+            <a:r>
+              <a:t>Slide 6 — Own pubs by outcome (person-level)</a:t>
+            </a:r>
+          </a:p>
+          <a:p>
+            <a:pPr>
+              <a:defRPr sz="1200" i="1"/>
+            </a:pPr>
+            <a:r>
+              <a:t>Tenured vs attrition vs censored · same HERO N</a:t>
+            </a:r>
+          </a:p>
+        </p:txBody>
+      </p:sp>
+      <p:sp>
+        <p:nvSpPr>
+          <p:cNvPr id="3" name="TextBox 2"/>
+          <p:cNvSpPr txBox="1"/>
+          <p:nvPr/>
+        </p:nvSpPr>
+        <p:spPr>
+          <a:xfrm>
+            <a:off x="411480" y="777240"/>
+            <a:ext cx="11368735" cy="713232"/>
+          </a:xfrm>
+          <a:prstGeom prst="rect">
+            <a:avLst/>
+          </a:prstGeom>
+          <a:noFill/>
+        </p:spPr>
+        <p:txBody>
+          <a:bodyPr wrap="square">
+            <a:spAutoFit/>
+          </a:bodyPr>
+          <a:lstStyle/>
+          <a:p>
+            <a:pPr>
+              <a:spcAft>
+                <a:spcPts val="200"/>
+              </a:spcAft>
+              <a:defRPr sz="1100"/>
+            </a:pPr>
+            <a:r>
+              <a:t>• Person-level mean pubs_year over assistant spell — descriptive, not HERO.</a:t>
+            </a:r>
+          </a:p>
+          <a:p>
+            <a:pPr>
+              <a:spcAft>
+                <a:spcPts val="200"/>
+              </a:spcAft>
+              <a:defRPr sz="1100"/>
+            </a:pPr>
+            <a:r>
+              <a:t>• Blue = promoted (tenure_event); orange = left as assistant; gray = still asst ≈ 2024.</a:t>
+            </a:r>
+          </a:p>
+          <a:p>
+            <a:pPr>
+              <a:spcAft>
+                <a:spcPts val="200"/>
+              </a:spcAft>
+              <a:defRPr sz="1100"/>
+            </a:pPr>
+            <a:r>
+              <a:t>• Compares own output to the LOO environment HERO bins on.</a:t>
+            </a:r>
+          </a:p>
+        </p:txBody>
+      </p:sp>
+      <p:pic>
+        <p:nvPicPr>
+          <p:cNvPr id="4" name="Picture 3" descr="TENURE_pubs_mean_by_outcome_infHM.png"/>
+          <p:cNvPicPr>
+            <a:picLocks noChangeAspect="1"/>
+          </p:cNvPicPr>
+          <p:nvPr/>
+        </p:nvPicPr>
+        <p:blipFill>
+          <a:blip r:embed="rId2"/>
+          <a:stretch>
+            <a:fillRect/>
+          </a:stretch>
+        </p:blipFill>
+        <p:spPr>
+          <a:xfrm>
+            <a:off x="2935368" y="1545336"/>
+            <a:ext cx="6320958" cy="3877056"/>
+          </a:xfrm>
+          <a:prstGeom prst="rect">
+            <a:avLst/>
+          </a:prstGeom>
+        </p:spPr>
+      </p:pic>
+      <p:sp>
+        <p:nvSpPr>
+          <p:cNvPr id="5" name="TextBox 4"/>
+          <p:cNvSpPr txBox="1"/>
+          <p:nvPr/>
+        </p:nvSpPr>
+        <p:spPr>
+          <a:xfrm>
+            <a:off x="411480" y="5495544"/>
+            <a:ext cx="11368735" cy="502920"/>
+          </a:xfrm>
+          <a:prstGeom prst="rect">
+            <a:avLst/>
+          </a:prstGeom>
+          <a:noFill/>
+        </p:spPr>
+        <p:txBody>
+          <a:bodyPr wrap="square" anchor="t">
+            <a:spAutoFit/>
+          </a:bodyPr>
+          <a:lstStyle/>
+          <a:p>
+            <a:pPr algn="l">
+              <a:defRPr sz="800">
+                <a:latin typeface="Menlo"/>
+              </a:defRPr>
+            </a:pPr>
+            <a:r>
+              <a:t>python tenure/scripts/tenure_basic_plots.py --only pubs_by_outcome</a:t>
+            </a:r>
+          </a:p>
+        </p:txBody>
+      </p:sp>
+      <p:sp>
+        <p:nvSpPr>
+          <p:cNvPr id="6" name="TextBox 5"/>
+          <p:cNvSpPr txBox="1"/>
+          <p:nvPr/>
+        </p:nvSpPr>
+        <p:spPr>
+          <a:xfrm>
+            <a:off x="411480" y="6035040"/>
+            <a:ext cx="11368735" cy="384048"/>
+          </a:xfrm>
+          <a:prstGeom prst="rect">
+            <a:avLst/>
+          </a:prstGeom>
+          <a:noFill/>
+        </p:spPr>
+        <p:txBody>
+          <a:bodyPr wrap="square">
+            <a:spAutoFit/>
+          </a:bodyPr>
+          <a:lstStyle/>
+          <a:p>
+            <a:pPr>
+              <a:defRPr sz="1000"/>
+            </a:pPr>
+            <a:r>
+              <a:t>tenured n=174 med=6.2 · attrition n=202 med=3.0 · censored n=420 med=2.0</a:t>
+            </a:r>
+          </a:p>
+        </p:txBody>
+      </p:sp>
+    </p:spTree>
+  </p:cSld>
+  <p:clrMapOvr>
+    <a:masterClrMapping/>
+  </p:clrMapOvr>
+</p:sld>
+</file>
+
+<file path=ppt/slides/slide8.xml><?xml version="1.0" encoding="utf-8"?>
+<p:sld xmlns:a="http://schemas.openxmlformats.org/drawingml/2006/main" xmlns:p="http://schemas.openxmlformats.org/presentationml/2006/main" xmlns:r="http://schemas.openxmlformats.org/officeDocument/2006/relationships">
+  <p:cSld>
+    <p:spTree>
+      <p:nvGrpSpPr>
+        <p:cNvPr id="1" name=""/>
+        <p:cNvGrpSpPr/>
+        <p:nvPr/>
+      </p:nvGrpSpPr>
+      <p:grpSpPr/>
+      <p:sp>
+        <p:nvSpPr>
+          <p:cNvPr id="2" name="TextBox 1"/>
+          <p:cNvSpPr txBox="1"/>
+          <p:nvPr/>
+        </p:nvSpPr>
+        <p:spPr>
+          <a:xfrm>
+            <a:off x="411480" y="201168"/>
+            <a:ext cx="11368735" cy="502920"/>
+          </a:xfrm>
+          <a:prstGeom prst="rect">
+            <a:avLst/>
+          </a:prstGeom>
+          <a:noFill/>
+        </p:spPr>
+        <p:txBody>
+          <a:bodyPr wrap="square">
+            <a:spAutoFit/>
+          </a:bodyPr>
+          <a:lstStyle/>
+          <a:p>
+            <a:pPr>
+              <a:defRPr b="1" sz="2000"/>
+            </a:pPr>
+            <a:r>
+              <a:t>Slide 7 — Promoted instructors — own pubs</a:t>
+            </a:r>
+          </a:p>
+          <a:p>
+            <a:pPr>
+              <a:defRPr sz="1200" i="1"/>
+            </a:pPr>
+            <a:r>
+              <a:t>Tenured only · person-level mean + inset (mean &gt; 0)</a:t>
+            </a:r>
+          </a:p>
+        </p:txBody>
+      </p:sp>
+      <p:sp>
+        <p:nvSpPr>
+          <p:cNvPr id="3" name="TextBox 2"/>
+          <p:cNvSpPr txBox="1"/>
+          <p:nvPr/>
+        </p:nvSpPr>
+        <p:spPr>
+          <a:xfrm>
+            <a:off x="411480" y="777240"/>
+            <a:ext cx="11368735" cy="713232"/>
+          </a:xfrm>
+          <a:prstGeom prst="rect">
+            <a:avLst/>
+          </a:prstGeom>
+          <a:noFill/>
+        </p:spPr>
+        <p:txBody>
+          <a:bodyPr wrap="square">
+            <a:spAutoFit/>
+          </a:bodyPr>
+          <a:lstStyle/>
+          <a:p>
+            <a:pPr>
+              <a:spcAft>
+                <a:spcPts val="200"/>
+              </a:spcAft>
+              <a:defRPr sz="1100"/>
+            </a:pPr>
+            <a:r>
+              <a:t>• Subset to tenure_event = True (N≈174 on inference panel).</a:t>
+            </a:r>
+          </a:p>
+          <a:p>
+            <a:pPr>
+              <a:spcAft>
+                <a:spcPts val="200"/>
+              </a:spcAft>
+              <a:defRPr sz="1100"/>
+            </a:pPr>
+            <a:r>
+              <a:t>• Mean annual pubs over assistant years — not cumulative career total.</a:t>
+            </a:r>
+          </a:p>
+          <a:p>
+            <a:pPr>
+              <a:spcAft>
+                <a:spcPts val="200"/>
+              </a:spcAft>
+              <a:defRPr sz="1100"/>
+            </a:pPr>
+            <a:r>
+              <a:t>• Pairs with HERO high-bin tenure rates; inset drops zero-mean spells.</a:t>
+            </a:r>
+          </a:p>
+        </p:txBody>
+      </p:sp>
+      <p:pic>
+        <p:nvPicPr>
+          <p:cNvPr id="4" name="Picture 3" descr="TENURE_pubs_mean_tenured_infHM.png"/>
+          <p:cNvPicPr>
+            <a:picLocks noChangeAspect="1"/>
+          </p:cNvPicPr>
+          <p:nvPr/>
+        </p:nvPicPr>
+        <p:blipFill>
+          <a:blip r:embed="rId2"/>
+          <a:stretch>
+            <a:fillRect/>
+          </a:stretch>
+        </p:blipFill>
+        <p:spPr>
+          <a:xfrm>
+            <a:off x="2932854" y="1545336"/>
+            <a:ext cx="6325987" cy="3877056"/>
+          </a:xfrm>
+          <a:prstGeom prst="rect">
+            <a:avLst/>
+          </a:prstGeom>
+        </p:spPr>
+      </p:pic>
+      <p:sp>
+        <p:nvSpPr>
+          <p:cNvPr id="5" name="TextBox 4"/>
+          <p:cNvSpPr txBox="1"/>
+          <p:nvPr/>
+        </p:nvSpPr>
+        <p:spPr>
+          <a:xfrm>
+            <a:off x="411480" y="5495544"/>
+            <a:ext cx="11368735" cy="502920"/>
+          </a:xfrm>
+          <a:prstGeom prst="rect">
+            <a:avLst/>
+          </a:prstGeom>
+          <a:noFill/>
+        </p:spPr>
+        <p:txBody>
+          <a:bodyPr wrap="square" anchor="t">
+            <a:spAutoFit/>
+          </a:bodyPr>
+          <a:lstStyle/>
+          <a:p>
+            <a:pPr algn="l">
+              <a:defRPr sz="800">
+                <a:latin typeface="Menlo"/>
+              </a:defRPr>
+            </a:pPr>
+            <a:r>
+              <a:t>python tenure/scripts/tenure_basic_plots.py --only pubs_tenured</a:t>
+            </a:r>
+          </a:p>
+        </p:txBody>
+      </p:sp>
+      <p:sp>
+        <p:nvSpPr>
+          <p:cNvPr id="6" name="TextBox 5"/>
+          <p:cNvSpPr txBox="1"/>
+          <p:nvPr/>
+        </p:nvSpPr>
+        <p:spPr>
+          <a:xfrm>
+            <a:off x="411480" y="6035040"/>
+            <a:ext cx="11368735" cy="384048"/>
+          </a:xfrm>
+          <a:prstGeom prst="rect">
+            <a:avLst/>
+          </a:prstGeom>
+          <a:noFill/>
+        </p:spPr>
+        <p:txBody>
+          <a:bodyPr wrap="square">
+            <a:spAutoFit/>
+          </a:bodyPr>
+          <a:lstStyle/>
+          <a:p>
+            <a:pPr>
+              <a:defRPr sz="1000"/>
+            </a:pPr>
+            <a:r>
+              <a:t>tenured n=174 · med=6.2 · mean=7.7 · inset n=133</a:t>
+            </a:r>
+          </a:p>
+        </p:txBody>
+      </p:sp>
+    </p:spTree>
+  </p:cSld>
+  <p:clrMapOvr>
+    <a:masterClrMapping/>
+  </p:clrMapOvr>
+</p:sld>
+</file>
+
+<file path=ppt/slides/slide9.xml><?xml version="1.0" encoding="utf-8"?>
+<p:sld xmlns:a="http://schemas.openxmlformats.org/drawingml/2006/main" xmlns:p="http://schemas.openxmlformats.org/presentationml/2006/main" xmlns:r="http://schemas.openxmlformats.org/officeDocument/2006/relationships">
+  <p:cSld>
+    <p:spTree>
+      <p:nvGrpSpPr>
+        <p:cNvPr id="1" name=""/>
+        <p:cNvGrpSpPr/>
+        <p:nvPr/>
+      </p:nvGrpSpPr>
+      <p:grpSpPr/>
+      <p:sp>
+        <p:nvSpPr>
+          <p:cNvPr id="2" name="TextBox 1"/>
+          <p:cNvSpPr txBox="1"/>
+          <p:nvPr/>
+        </p:nvSpPr>
+        <p:spPr>
+          <a:xfrm>
+            <a:off x="411480" y="201168"/>
+            <a:ext cx="11368735" cy="502920"/>
+          </a:xfrm>
+          <a:prstGeom prst="rect">
+            <a:avLst/>
+          </a:prstGeom>
+          <a:noFill/>
+        </p:spPr>
+        <p:txBody>
+          <a:bodyPr wrap="square">
+            <a:spAutoFit/>
+          </a:bodyPr>
+          <a:lstStyle/>
+          <a:p>
+            <a:pPr>
+              <a:defRPr b="1" sz="2000"/>
+            </a:pPr>
+            <a:r>
+              <a:t>Slide 8 — poolq_LOO by outcome (person-level)</a:t>
+            </a:r>
+          </a:p>
+          <a:p>
+            <a:pPr>
+              <a:defRPr sz="1200" i="1"/>
+            </a:pPr>
+            <a:r>
+              <a:t>Peer environment split · complements HERO x-axis</a:t>
+            </a:r>
+          </a:p>
+        </p:txBody>
+      </p:sp>
+      <p:sp>
+        <p:nvSpPr>
+          <p:cNvPr id="3" name="TextBox 2"/>
+          <p:cNvSpPr txBox="1"/>
+          <p:nvPr/>
+        </p:nvSpPr>
+        <p:spPr>
+          <a:xfrm>
+            <a:off x="411480" y="777240"/>
+            <a:ext cx="11368735" cy="713232"/>
+          </a:xfrm>
+          <a:prstGeom prst="rect">
+            <a:avLst/>
+          </a:prstGeom>
+          <a:noFill/>
+        </p:spPr>
+        <p:txBody>
+          <a:bodyPr wrap="square">
+            <a:spAutoFit/>
+          </a:bodyPr>
+          <a:lstStyle/>
+          <a:p>
+            <a:pPr>
+              <a:spcAft>
+                <a:spcPts val="200"/>
+              </a:spcAft>
+              <a:defRPr sz="1100"/>
+            </a:pPr>
+            <a:r>
+              <a:t>• Same outcome colors as pubs-by-outcome slide.</a:t>
+            </a:r>
+          </a:p>
+          <a:p>
+            <a:pPr>
+              <a:spcAft>
+                <a:spcPts val="200"/>
+              </a:spcAft>
+              <a:defRPr sz="1100"/>
+            </a:pPr>
+            <a:r>
+              <a:t>• Shows whether promoted faculty carried higher LOO peer pressure on average.</a:t>
+            </a:r>
+          </a:p>
+          <a:p>
+            <a:pPr>
+              <a:spcAft>
+                <a:spcPts val="200"/>
+              </a:spcAft>
+              <a:defRPr sz="1100"/>
+            </a:pPr>
+            <a:r>
+              <a:t>• HERO asks rate(T|LOO bin); this is marginal LOO by outcome.</a:t>
+            </a:r>
+          </a:p>
+        </p:txBody>
+      </p:sp>
+      <p:pic>
+        <p:nvPicPr>
+          <p:cNvPr id="4" name="Picture 3" descr="TENURE_poolq_loo_by_outcome_infHM.png"/>
+          <p:cNvPicPr>
+            <a:picLocks noChangeAspect="1"/>
+          </p:cNvPicPr>
+          <p:nvPr/>
+        </p:nvPicPr>
+        <p:blipFill>
+          <a:blip r:embed="rId2"/>
+          <a:stretch>
+            <a:fillRect/>
+          </a:stretch>
+        </p:blipFill>
+        <p:spPr>
+          <a:xfrm>
+            <a:off x="2930340" y="1545336"/>
+            <a:ext cx="6331015" cy="3877056"/>
+          </a:xfrm>
+          <a:prstGeom prst="rect">
+            <a:avLst/>
+          </a:prstGeom>
+        </p:spPr>
+      </p:pic>
+      <p:sp>
+        <p:nvSpPr>
+          <p:cNvPr id="5" name="TextBox 4"/>
+          <p:cNvSpPr txBox="1"/>
+          <p:nvPr/>
+        </p:nvSpPr>
+        <p:spPr>
+          <a:xfrm>
+            <a:off x="411480" y="5495544"/>
+            <a:ext cx="11368735" cy="502920"/>
+          </a:xfrm>
+          <a:prstGeom prst="rect">
+            <a:avLst/>
+          </a:prstGeom>
+          <a:noFill/>
+        </p:spPr>
+        <p:txBody>
+          <a:bodyPr wrap="square" anchor="t">
+            <a:spAutoFit/>
+          </a:bodyPr>
+          <a:lstStyle/>
+          <a:p>
+            <a:pPr algn="l">
+              <a:defRPr sz="800">
+                <a:latin typeface="Menlo"/>
+              </a:defRPr>
+            </a:pPr>
+            <a:r>
+              <a:t>python tenure/scripts/tenure_basic_plots.py --only loo_by_outcome</a:t>
+            </a:r>
+          </a:p>
+        </p:txBody>
+      </p:sp>
+      <p:sp>
+        <p:nvSpPr>
+          <p:cNvPr id="6" name="TextBox 5"/>
+          <p:cNvSpPr txBox="1"/>
+          <p:nvPr/>
+        </p:nvSpPr>
+        <p:spPr>
+          <a:xfrm>
+            <a:off x="411480" y="6035040"/>
+            <a:ext cx="11368735" cy="384048"/>
+          </a:xfrm>
+          <a:prstGeom prst="rect">
+            <a:avLst/>
+          </a:prstGeom>
+          <a:noFill/>
+        </p:spPr>
+        <p:txBody>
+          <a:bodyPr wrap="square">
+            <a:spAutoFit/>
+          </a:bodyPr>
+          <a:lstStyle/>
+          <a:p>
+            <a:pPr>
+              <a:defRPr sz="1000"/>
+            </a:pPr>
+            <a:r>
+              <a:t>tenured n=174 med=3.8 · attrition n=202 med=3.5 · censored n=420 med=3.2</a:t>
             </a:r>
           </a:p>
         </p:txBody>

</xml_diff>

<commit_message>
Add Slurm job script and new author-year career master documentation
- Introduced a new Slurm job script `build_author_year_career_master.slurm` for building a flat author×calendar-year table from OpenAlex works, facilitating tenure analysis.
- Added `20260902_COMPASS_to_PEER_author_year_career_master.md` to document the process and deliverables for the author-year career master table.
- Created new binary files for the author-year career master outputs, enhancing the analytical capabilities for tenure evaluations.
- Updated statistics in `statistics.json` to reflect the latest user and agent message counts, ensuring accurate tracking of project activity.
- Gitignore Big Fish unzipped CSVs (>100MB football panel); track zip archives only.

These changes improve the framework for author-year analysis, providing clearer guidance and enhanced capabilities for performance evaluation.

Co-authored-by: Cursor <cursoragent@cursor.com>
</commit_message>
<xml_diff>
--- a/3-Master_Plan/re_entry/HEROs_and_PASSes/tenure_sandbox/basic_data_plots/TENURE_BDP_slides_AUTO.pptx
+++ b/3-Master_Plan/re_entry/HEROs_and_PASSes/tenure_sandbox/basic_data_plots/TENURE_BDP_slides_AUTO.pptx
@@ -14,6 +14,13 @@
     <p:sldId id="262" r:id="rId13"/>
     <p:sldId id="263" r:id="rId14"/>
     <p:sldId id="264" r:id="rId15"/>
+    <p:sldId id="265" r:id="rId16"/>
+    <p:sldId id="266" r:id="rId17"/>
+    <p:sldId id="267" r:id="rId18"/>
+    <p:sldId id="268" r:id="rId19"/>
+    <p:sldId id="269" r:id="rId20"/>
+    <p:sldId id="270" r:id="rId21"/>
+    <p:sldId id="271" r:id="rId22"/>
   </p:sldIdLst>
   <p:sldSz cx="12191695" cy="6858000" type="screen4x3"/>
   <p:notesSz cx="6858000" cy="9144000"/>
@@ -3130,7 +3137,7 @@
               <a:defRPr sz="1200" i="1"/>
             </a:pPr>
             <a:r>
-              <a:t>2026-09-01</a:t>
+              <a:t>2026-09-02</a:t>
             </a:r>
           </a:p>
         </p:txBody>
@@ -3164,7 +3171,7 @@
               <a:defRPr sz="1100"/>
             </a:pPr>
             <a:r>
-              <a:t>• Tenure HERO population: HIGH + MEDIUM OpenAlex inference · LOO computable on assistant rows.</a:t>
+              <a:t>• Tenure porch BDP: HIGH + MEDIUM OpenAlex inference · LOO computable.</a:t>
             </a:r>
           </a:p>
           <a:p>
@@ -3175,7 +3182,7 @@
               <a:defRPr sz="1100"/>
             </a:pPr>
             <a:r>
-              <a:t>• HERO lock: person-level mean poolq_LOO · Q16 quantile (Q20 for dip robustness).</a:t>
+              <a:t>• v0 section: ASST-PS uni×year assistant pools (exploratory lock).</a:t>
             </a:r>
           </a:p>
           <a:p>
@@ -3186,7 +3193,18 @@
               <a:defRPr sz="1100"/>
             </a:pPr>
             <a:r>
-              <a:t>• Rates: tenure among resolved (Option A); censored excluded from denominator.</a:t>
+              <a:t>• PD29 section: decision cohort · asst_time · pubs_per_career_year · dept pond LOO.</a:t>
+            </a:r>
+          </a:p>
+          <a:p>
+            <a:pPr>
+              <a:spcAft>
+                <a:spcPts val="200"/>
+              </a:spcAft>
+              <a:defRPr sz="1100"/>
+            </a:pPr>
+            <a:r>
+              <a:t>• HERO rate plots: TENURE_HERO_slides_AUTO.pptx (decision dept LOO = primary).</a:t>
             </a:r>
           </a:p>
         </p:txBody>
@@ -3224,6 +3242,1292 @@
             <a:br/>
             <a:r>
               <a:t>python tenure/scripts/build_tenure_basic_plots_slides.py</a:t>
+            </a:r>
+          </a:p>
+        </p:txBody>
+      </p:sp>
+    </p:spTree>
+  </p:cSld>
+  <p:clrMapOvr>
+    <a:masterClrMapping/>
+  </p:clrMapOvr>
+</p:sld>
+</file>
+
+<file path=ppt/slides/slide10.xml><?xml version="1.0" encoding="utf-8"?>
+<p:sld xmlns:a="http://schemas.openxmlformats.org/drawingml/2006/main" xmlns:p="http://schemas.openxmlformats.org/presentationml/2006/main" xmlns:r="http://schemas.openxmlformats.org/officeDocument/2006/relationships">
+  <p:cSld>
+    <p:spTree>
+      <p:nvGrpSpPr>
+        <p:cNvPr id="1" name=""/>
+        <p:cNvGrpSpPr/>
+        <p:nvPr/>
+      </p:nvGrpSpPr>
+      <p:grpSpPr/>
+      <p:sp>
+        <p:nvSpPr>
+          <p:cNvPr id="2" name="TextBox 1"/>
+          <p:cNvSpPr txBox="1"/>
+          <p:nvPr/>
+        </p:nvSpPr>
+        <p:spPr>
+          <a:xfrm>
+            <a:off x="411480" y="201168"/>
+            <a:ext cx="11368735" cy="502920"/>
+          </a:xfrm>
+          <a:prstGeom prst="rect">
+            <a:avLst/>
+          </a:prstGeom>
+          <a:noFill/>
+        </p:spPr>
+        <p:txBody>
+          <a:bodyPr wrap="square">
+            <a:spAutoFit/>
+          </a:bodyPr>
+          <a:lstStyle/>
+          <a:p>
+            <a:pPr>
+              <a:defRPr b="1" sz="2000"/>
+            </a:pPr>
+            <a:r>
+              <a:t>Decision cohort — basic data plots (PD29)</a:t>
+            </a:r>
+          </a:p>
+          <a:p>
+            <a:pPr>
+              <a:defRPr sz="1200" i="1"/>
+            </a:pPr>
+            <a:r>
+              <a:t>2026-09-02 · rebuilt panel · new metrics</a:t>
+            </a:r>
+          </a:p>
+        </p:txBody>
+      </p:sp>
+      <p:sp>
+        <p:nvSpPr>
+          <p:cNvPr id="3" name="TextBox 2"/>
+          <p:cNvSpPr txBox="1"/>
+          <p:nvPr/>
+        </p:nvSpPr>
+        <p:spPr>
+          <a:xfrm>
+            <a:off x="411480" y="1005840"/>
+            <a:ext cx="11368735" cy="1234440"/>
+          </a:xfrm>
+          <a:prstGeom prst="rect">
+            <a:avLst/>
+          </a:prstGeom>
+          <a:noFill/>
+        </p:spPr>
+        <p:txBody>
+          <a:bodyPr wrap="square">
+            <a:spAutoFit/>
+          </a:bodyPr>
+          <a:lstStyle/>
+          <a:p>
+            <a:pPr>
+              <a:spcAft>
+                <a:spcPts val="200"/>
+              </a:spcAft>
+              <a:defRPr sz="1100"/>
+            </a:pPr>
+            <a:r>
+              <a:t>• Resolved = tenure or attrition (incl. off_tenure_track). Excl. censored + transferred.</a:t>
+            </a:r>
+          </a:p>
+          <a:p>
+            <a:pPr>
+              <a:spcAft>
+                <a:spcPts val="200"/>
+              </a:spcAft>
+              <a:defRPr sz="1100"/>
+            </a:pPr>
+            <a:r>
+              <a:t>• Metrics: asst_time · own pubs_per_career_year · dept pond LOO (whole dept, you excluded).</a:t>
+            </a:r>
+          </a:p>
+          <a:p>
+            <a:pPr>
+              <a:spcAft>
+                <a:spcPts val="200"/>
+              </a:spcAft>
+              <a:defRPr sz="1100"/>
+            </a:pPr>
+            <a:r>
+              <a:t>• Reference band asst_time 5–6 shaded on timing plot only — not an inclusion filter.</a:t>
+            </a:r>
+          </a:p>
+        </p:txBody>
+      </p:sp>
+    </p:spTree>
+  </p:cSld>
+  <p:clrMapOvr>
+    <a:masterClrMapping/>
+  </p:clrMapOvr>
+</p:sld>
+</file>
+
+<file path=ppt/slides/slide11.xml><?xml version="1.0" encoding="utf-8"?>
+<p:sld xmlns:a="http://schemas.openxmlformats.org/drawingml/2006/main" xmlns:p="http://schemas.openxmlformats.org/presentationml/2006/main" xmlns:r="http://schemas.openxmlformats.org/officeDocument/2006/relationships">
+  <p:cSld>
+    <p:spTree>
+      <p:nvGrpSpPr>
+        <p:cNvPr id="1" name=""/>
+        <p:cNvGrpSpPr/>
+        <p:nvPr/>
+      </p:nvGrpSpPr>
+      <p:grpSpPr/>
+      <p:sp>
+        <p:nvSpPr>
+          <p:cNvPr id="2" name="TextBox 1"/>
+          <p:cNvSpPr txBox="1"/>
+          <p:nvPr/>
+        </p:nvSpPr>
+        <p:spPr>
+          <a:xfrm>
+            <a:off x="411480" y="201168"/>
+            <a:ext cx="11368735" cy="502920"/>
+          </a:xfrm>
+          <a:prstGeom prst="rect">
+            <a:avLst/>
+          </a:prstGeom>
+          <a:noFill/>
+        </p:spPr>
+        <p:txBody>
+          <a:bodyPr wrap="square">
+            <a:spAutoFit/>
+          </a:bodyPr>
+          <a:lstStyle/>
+          <a:p>
+            <a:pPr>
+              <a:defRPr b="1" sz="2000"/>
+            </a:pPr>
+            <a:r>
+              <a:t>Slide 9 — Assistant time at exit (all resolved)</a:t>
+            </a:r>
+          </a:p>
+          <a:p>
+            <a:pPr>
+              <a:defRPr sz="1200" i="1"/>
+            </a:pPr>
+            <a:r>
+              <a:t>exit cross-section · Reference band asst_time 5–6 shaded · not a filter</a:t>
+            </a:r>
+          </a:p>
+        </p:txBody>
+      </p:sp>
+      <p:sp>
+        <p:nvSpPr>
+          <p:cNvPr id="3" name="TextBox 2"/>
+          <p:cNvSpPr txBox="1"/>
+          <p:nvPr/>
+        </p:nvSpPr>
+        <p:spPr>
+          <a:xfrm>
+            <a:off x="411480" y="777240"/>
+            <a:ext cx="11368735" cy="713232"/>
+          </a:xfrm>
+          <a:prstGeom prst="rect">
+            <a:avLst/>
+          </a:prstGeom>
+          <a:noFill/>
+        </p:spPr>
+        <p:txBody>
+          <a:bodyPr wrap="square">
+            <a:spAutoFit/>
+          </a:bodyPr>
+          <a:lstStyle/>
+          <a:p>
+            <a:pPr>
+              <a:spcAft>
+                <a:spcPts val="200"/>
+              </a:spcAft>
+              <a:defRPr sz="1100"/>
+            </a:pPr>
+            <a:r>
+              <a:t>• 391 resolved infHM at last assistant year (excl. transferred).</a:t>
+            </a:r>
+          </a:p>
+          <a:p>
+            <a:pPr>
+              <a:spcAft>
+                <a:spcPts val="200"/>
+              </a:spcAft>
+              <a:defRPr sz="1100"/>
+            </a:pPr>
+            <a:r>
+              <a:t>• Dept-year censoring + off-tenure-track attrition on rebuilt panel.</a:t>
+            </a:r>
+          </a:p>
+          <a:p>
+            <a:pPr>
+              <a:spcAft>
+                <a:spcPts val="200"/>
+              </a:spcAft>
+              <a:defRPr sz="1100"/>
+            </a:pPr>
+            <a:r>
+              <a:t>• Most exits early (asst_time 1–4); band 5–6 = Alex expected clock (63 people, 16%).</a:t>
+            </a:r>
+          </a:p>
+        </p:txBody>
+      </p:sp>
+      <p:pic>
+        <p:nvPicPr>
+          <p:cNvPr id="4" name="Picture 3" descr="TENURE_decision_asst_time_exit_pd29.png"/>
+          <p:cNvPicPr>
+            <a:picLocks noChangeAspect="1"/>
+          </p:cNvPicPr>
+          <p:nvPr/>
+        </p:nvPicPr>
+        <p:blipFill>
+          <a:blip r:embed="rId2"/>
+          <a:stretch>
+            <a:fillRect/>
+          </a:stretch>
+        </p:blipFill>
+        <p:spPr>
+          <a:xfrm>
+            <a:off x="2968849" y="1545336"/>
+            <a:ext cx="6253997" cy="3877056"/>
+          </a:xfrm>
+          <a:prstGeom prst="rect">
+            <a:avLst/>
+          </a:prstGeom>
+        </p:spPr>
+      </p:pic>
+      <p:sp>
+        <p:nvSpPr>
+          <p:cNvPr id="5" name="TextBox 4"/>
+          <p:cNvSpPr txBox="1"/>
+          <p:nvPr/>
+        </p:nvSpPr>
+        <p:spPr>
+          <a:xfrm>
+            <a:off x="411480" y="5495544"/>
+            <a:ext cx="11368735" cy="502920"/>
+          </a:xfrm>
+          <a:prstGeom prst="rect">
+            <a:avLst/>
+          </a:prstGeom>
+          <a:noFill/>
+        </p:spPr>
+        <p:txBody>
+          <a:bodyPr wrap="square" anchor="t">
+            <a:spAutoFit/>
+          </a:bodyPr>
+          <a:lstStyle/>
+          <a:p>
+            <a:pPr algn="l">
+              <a:defRPr sz="800">
+                <a:latin typeface="Menlo"/>
+              </a:defRPr>
+            </a:pPr>
+            <a:r>
+              <a:t>python tenure/scripts/tenure_basic_plots.py --mode pd29 --only decision_asst_time</a:t>
+            </a:r>
+          </a:p>
+        </p:txBody>
+      </p:sp>
+      <p:sp>
+        <p:nvSpPr>
+          <p:cNvPr id="6" name="TextBox 5"/>
+          <p:cNvSpPr txBox="1"/>
+          <p:nvPr/>
+        </p:nvSpPr>
+        <p:spPr>
+          <a:xfrm>
+            <a:off x="411480" y="6035040"/>
+            <a:ext cx="11368735" cy="384048"/>
+          </a:xfrm>
+          <a:prstGeom prst="rect">
+            <a:avLst/>
+          </a:prstGeom>
+          <a:noFill/>
+        </p:spPr>
+        <p:txBody>
+          <a:bodyPr wrap="square">
+            <a:spAutoFit/>
+          </a:bodyPr>
+          <a:lstStyle/>
+          <a:p>
+            <a:pPr>
+              <a:defRPr sz="1000"/>
+            </a:pPr>
+            <a:r>
+              <a:t>resolved=391 · in reference band=63</a:t>
+            </a:r>
+          </a:p>
+        </p:txBody>
+      </p:sp>
+    </p:spTree>
+  </p:cSld>
+  <p:clrMapOvr>
+    <a:masterClrMapping/>
+  </p:clrMapOvr>
+</p:sld>
+</file>
+
+<file path=ppt/slides/slide12.xml><?xml version="1.0" encoding="utf-8"?>
+<p:sld xmlns:a="http://schemas.openxmlformats.org/drawingml/2006/main" xmlns:p="http://schemas.openxmlformats.org/presentationml/2006/main" xmlns:r="http://schemas.openxmlformats.org/officeDocument/2006/relationships">
+  <p:cSld>
+    <p:spTree>
+      <p:nvGrpSpPr>
+        <p:cNvPr id="1" name=""/>
+        <p:cNvGrpSpPr/>
+        <p:nvPr/>
+      </p:nvGrpSpPr>
+      <p:grpSpPr/>
+      <p:sp>
+        <p:nvSpPr>
+          <p:cNvPr id="2" name="TextBox 1"/>
+          <p:cNvSpPr txBox="1"/>
+          <p:nvPr/>
+        </p:nvSpPr>
+        <p:spPr>
+          <a:xfrm>
+            <a:off x="411480" y="201168"/>
+            <a:ext cx="11368735" cy="502920"/>
+          </a:xfrm>
+          <a:prstGeom prst="rect">
+            <a:avLst/>
+          </a:prstGeom>
+          <a:noFill/>
+        </p:spPr>
+        <p:txBody>
+          <a:bodyPr wrap="square">
+            <a:spAutoFit/>
+          </a:bodyPr>
+          <a:lstStyle/>
+          <a:p>
+            <a:pPr>
+              <a:defRPr b="1" sz="2000"/>
+            </a:pPr>
+            <a:r>
+              <a:t>Slide 10 — Own career pubs rate at decision (Alex Â)</a:t>
+            </a:r>
+          </a:p>
+          <a:p>
+            <a:pPr>
+              <a:defRPr sz="1200" i="1"/>
+            </a:pPr>
+            <a:r>
+              <a:t>DECISION · cum ÷ career age · ability slice</a:t>
+            </a:r>
+          </a:p>
+        </p:txBody>
+      </p:sp>
+      <p:sp>
+        <p:nvSpPr>
+          <p:cNvPr id="3" name="TextBox 2"/>
+          <p:cNvSpPr txBox="1"/>
+          <p:nvPr/>
+        </p:nvSpPr>
+        <p:spPr>
+          <a:xfrm>
+            <a:off x="411480" y="777240"/>
+            <a:ext cx="11368735" cy="713232"/>
+          </a:xfrm>
+          <a:prstGeom prst="rect">
+            <a:avLst/>
+          </a:prstGeom>
+          <a:noFill/>
+        </p:spPr>
+        <p:txBody>
+          <a:bodyPr wrap="square">
+            <a:spAutoFit/>
+          </a:bodyPr>
+          <a:lstStyle/>
+          <a:p>
+            <a:pPr>
+              <a:spcAft>
+                <a:spcPts val="200"/>
+              </a:spcAft>
+              <a:defRPr sz="1100"/>
+            </a:pPr>
+            <a:r>
+              <a:t>• pubs_per_career_year from career master at decision calendar year.</a:t>
+            </a:r>
+          </a:p>
+          <a:p>
+            <a:pPr>
+              <a:spcAft>
+                <a:spcPts val="200"/>
+              </a:spcAft>
+              <a:defRPr sz="1100"/>
+            </a:pPr>
+            <a:r>
+              <a:t>• 280/391 with computable rate (OpenAlex coverage gap).</a:t>
+            </a:r>
+          </a:p>
+          <a:p>
+            <a:pPr>
+              <a:spcAft>
+                <a:spcPts val="200"/>
+              </a:spcAft>
+              <a:defRPr sz="1100"/>
+            </a:pPr>
+            <a:r>
+              <a:t>• Pairs with own-career HERO slide — not the peer-context X.</a:t>
+            </a:r>
+          </a:p>
+        </p:txBody>
+      </p:sp>
+      <p:pic>
+        <p:nvPicPr>
+          <p:cNvPr id="4" name="Picture 3" descr="TENURE_pubs_career_rate_pd29.png"/>
+          <p:cNvPicPr>
+            <a:picLocks noChangeAspect="1"/>
+          </p:cNvPicPr>
+          <p:nvPr/>
+        </p:nvPicPr>
+        <p:blipFill>
+          <a:blip r:embed="rId2"/>
+          <a:stretch>
+            <a:fillRect/>
+          </a:stretch>
+        </p:blipFill>
+        <p:spPr>
+          <a:xfrm>
+            <a:off x="2967227" y="1545336"/>
+            <a:ext cx="6257240" cy="3877056"/>
+          </a:xfrm>
+          <a:prstGeom prst="rect">
+            <a:avLst/>
+          </a:prstGeom>
+        </p:spPr>
+      </p:pic>
+      <p:sp>
+        <p:nvSpPr>
+          <p:cNvPr id="5" name="TextBox 4"/>
+          <p:cNvSpPr txBox="1"/>
+          <p:nvPr/>
+        </p:nvSpPr>
+        <p:spPr>
+          <a:xfrm>
+            <a:off x="411480" y="5495544"/>
+            <a:ext cx="11368735" cy="502920"/>
+          </a:xfrm>
+          <a:prstGeom prst="rect">
+            <a:avLst/>
+          </a:prstGeom>
+          <a:noFill/>
+        </p:spPr>
+        <p:txBody>
+          <a:bodyPr wrap="square" anchor="t">
+            <a:spAutoFit/>
+          </a:bodyPr>
+          <a:lstStyle/>
+          <a:p>
+            <a:pPr algn="l">
+              <a:defRPr sz="800">
+                <a:latin typeface="Menlo"/>
+              </a:defRPr>
+            </a:pPr>
+            <a:r>
+              <a:t>python tenure/scripts/tenure_basic_plots.py --mode pd29 --only career_rate</a:t>
+            </a:r>
+          </a:p>
+        </p:txBody>
+      </p:sp>
+      <p:sp>
+        <p:nvSpPr>
+          <p:cNvPr id="6" name="TextBox 5"/>
+          <p:cNvSpPr txBox="1"/>
+          <p:nvPr/>
+        </p:nvSpPr>
+        <p:spPr>
+          <a:xfrm>
+            <a:off x="411480" y="6035040"/>
+            <a:ext cx="11368735" cy="384048"/>
+          </a:xfrm>
+          <a:prstGeom prst="rect">
+            <a:avLst/>
+          </a:prstGeom>
+          <a:noFill/>
+        </p:spPr>
+        <p:txBody>
+          <a:bodyPr wrap="square">
+            <a:spAutoFit/>
+          </a:bodyPr>
+          <a:lstStyle/>
+          <a:p>
+            <a:pPr>
+              <a:defRPr sz="1000"/>
+            </a:pPr>
+            <a:r>
+              <a:t>n=280 · median=3.65 · mean=4.83 · sd=5.51</a:t>
+            </a:r>
+          </a:p>
+        </p:txBody>
+      </p:sp>
+    </p:spTree>
+  </p:cSld>
+  <p:clrMapOvr>
+    <a:masterClrMapping/>
+  </p:clrMapOvr>
+</p:sld>
+</file>
+
+<file path=ppt/slides/slide13.xml><?xml version="1.0" encoding="utf-8"?>
+<p:sld xmlns:a="http://schemas.openxmlformats.org/drawingml/2006/main" xmlns:p="http://schemas.openxmlformats.org/presentationml/2006/main" xmlns:r="http://schemas.openxmlformats.org/officeDocument/2006/relationships">
+  <p:cSld>
+    <p:spTree>
+      <p:nvGrpSpPr>
+        <p:cNvPr id="1" name=""/>
+        <p:cNvGrpSpPr/>
+        <p:nvPr/>
+      </p:nvGrpSpPr>
+      <p:grpSpPr/>
+      <p:sp>
+        <p:nvSpPr>
+          <p:cNvPr id="2" name="TextBox 1"/>
+          <p:cNvSpPr txBox="1"/>
+          <p:nvPr/>
+        </p:nvSpPr>
+        <p:spPr>
+          <a:xfrm>
+            <a:off x="411480" y="201168"/>
+            <a:ext cx="11368735" cy="502920"/>
+          </a:xfrm>
+          <a:prstGeom prst="rect">
+            <a:avLst/>
+          </a:prstGeom>
+          <a:noFill/>
+        </p:spPr>
+        <p:txBody>
+          <a:bodyPr wrap="square">
+            <a:spAutoFit/>
+          </a:bodyPr>
+          <a:lstStyle/>
+          <a:p>
+            <a:pPr>
+              <a:defRPr b="1" sz="2000"/>
+            </a:pPr>
+            <a:r>
+              <a:t>Slide 11 — Own career pubs rate by outcome</a:t>
+            </a:r>
+          </a:p>
+          <a:p>
+            <a:pPr>
+              <a:defRPr sz="1200" i="1"/>
+            </a:pPr>
+            <a:r>
+              <a:t>DECISION · Tenured vs attrition · ability slice</a:t>
+            </a:r>
+          </a:p>
+        </p:txBody>
+      </p:sp>
+      <p:sp>
+        <p:nvSpPr>
+          <p:cNvPr id="3" name="TextBox 2"/>
+          <p:cNvSpPr txBox="1"/>
+          <p:nvPr/>
+        </p:nvSpPr>
+        <p:spPr>
+          <a:xfrm>
+            <a:off x="411480" y="777240"/>
+            <a:ext cx="11368735" cy="713232"/>
+          </a:xfrm>
+          <a:prstGeom prst="rect">
+            <a:avLst/>
+          </a:prstGeom>
+          <a:noFill/>
+        </p:spPr>
+        <p:txBody>
+          <a:bodyPr wrap="square">
+            <a:spAutoFit/>
+          </a:bodyPr>
+          <a:lstStyle/>
+          <a:p>
+            <a:pPr>
+              <a:spcAft>
+                <a:spcPts val="200"/>
+              </a:spcAft>
+              <a:defRPr sz="1100"/>
+            </a:pPr>
+            <a:r>
+              <a:t>• Same career-rate metric split by tenure vs attrition (incl. OTT).</a:t>
+            </a:r>
+          </a:p>
+          <a:p>
+            <a:pPr>
+              <a:spcAft>
+                <a:spcPts val="200"/>
+              </a:spcAft>
+              <a:defRPr sz="1100"/>
+            </a:pPr>
+            <a:r>
+              <a:t>• Descriptive marginals — HERO bins on dept pond LOO, not own Â.</a:t>
+            </a:r>
+          </a:p>
+        </p:txBody>
+      </p:sp>
+      <p:pic>
+        <p:nvPicPr>
+          <p:cNvPr id="4" name="Picture 3" descr="TENURE_pubs_career_rate_by_outcome_pd29.png"/>
+          <p:cNvPicPr>
+            <a:picLocks noChangeAspect="1"/>
+          </p:cNvPicPr>
+          <p:nvPr/>
+        </p:nvPicPr>
+        <p:blipFill>
+          <a:blip r:embed="rId2"/>
+          <a:stretch>
+            <a:fillRect/>
+          </a:stretch>
+        </p:blipFill>
+        <p:spPr>
+          <a:xfrm>
+            <a:off x="2932854" y="1545336"/>
+            <a:ext cx="6325987" cy="3877056"/>
+          </a:xfrm>
+          <a:prstGeom prst="rect">
+            <a:avLst/>
+          </a:prstGeom>
+        </p:spPr>
+      </p:pic>
+      <p:sp>
+        <p:nvSpPr>
+          <p:cNvPr id="5" name="TextBox 4"/>
+          <p:cNvSpPr txBox="1"/>
+          <p:nvPr/>
+        </p:nvSpPr>
+        <p:spPr>
+          <a:xfrm>
+            <a:off x="411480" y="5495544"/>
+            <a:ext cx="11368735" cy="502920"/>
+          </a:xfrm>
+          <a:prstGeom prst="rect">
+            <a:avLst/>
+          </a:prstGeom>
+          <a:noFill/>
+        </p:spPr>
+        <p:txBody>
+          <a:bodyPr wrap="square" anchor="t">
+            <a:spAutoFit/>
+          </a:bodyPr>
+          <a:lstStyle/>
+          <a:p>
+            <a:pPr algn="l">
+              <a:defRPr sz="800">
+                <a:latin typeface="Menlo"/>
+              </a:defRPr>
+            </a:pPr>
+            <a:r>
+              <a:t>python tenure/scripts/tenure_basic_plots.py --mode pd29 --only career_rate_by_outcome</a:t>
+            </a:r>
+          </a:p>
+        </p:txBody>
+      </p:sp>
+      <p:sp>
+        <p:nvSpPr>
+          <p:cNvPr id="6" name="TextBox 5"/>
+          <p:cNvSpPr txBox="1"/>
+          <p:nvPr/>
+        </p:nvSpPr>
+        <p:spPr>
+          <a:xfrm>
+            <a:off x="411480" y="6035040"/>
+            <a:ext cx="11368735" cy="384048"/>
+          </a:xfrm>
+          <a:prstGeom prst="rect">
+            <a:avLst/>
+          </a:prstGeom>
+          <a:noFill/>
+        </p:spPr>
+        <p:txBody>
+          <a:bodyPr wrap="square">
+            <a:spAutoFit/>
+          </a:bodyPr>
+          <a:lstStyle/>
+          <a:p>
+            <a:pPr>
+              <a:defRPr sz="1000"/>
+            </a:pPr>
+            <a:r>
+              <a:t>tenured n=146 med=4.4 · attrition n=134 med=3.0</a:t>
+            </a:r>
+          </a:p>
+        </p:txBody>
+      </p:sp>
+    </p:spTree>
+  </p:cSld>
+  <p:clrMapOvr>
+    <a:masterClrMapping/>
+  </p:clrMapOvr>
+</p:sld>
+</file>
+
+<file path=ppt/slides/slide14.xml><?xml version="1.0" encoding="utf-8"?>
+<p:sld xmlns:a="http://schemas.openxmlformats.org/drawingml/2006/main" xmlns:p="http://schemas.openxmlformats.org/presentationml/2006/main" xmlns:r="http://schemas.openxmlformats.org/officeDocument/2006/relationships">
+  <p:cSld>
+    <p:spTree>
+      <p:nvGrpSpPr>
+        <p:cNvPr id="1" name=""/>
+        <p:cNvGrpSpPr/>
+        <p:nvPr/>
+      </p:nvGrpSpPr>
+      <p:grpSpPr/>
+      <p:sp>
+        <p:nvSpPr>
+          <p:cNvPr id="2" name="TextBox 1"/>
+          <p:cNvSpPr txBox="1"/>
+          <p:nvPr/>
+        </p:nvSpPr>
+        <p:spPr>
+          <a:xfrm>
+            <a:off x="411480" y="201168"/>
+            <a:ext cx="11368735" cy="502920"/>
+          </a:xfrm>
+          <a:prstGeom prst="rect">
+            <a:avLst/>
+          </a:prstGeom>
+          <a:noFill/>
+        </p:spPr>
+        <p:txBody>
+          <a:bodyPr wrap="square">
+            <a:spAutoFit/>
+          </a:bodyPr>
+          <a:lstStyle/>
+          <a:p>
+            <a:pPr>
+              <a:defRPr b="1" sz="2000"/>
+            </a:pPr>
+            <a:r>
+              <a:t>Slide 12 — Dept pond LOO career rate</a:t>
+            </a:r>
+          </a:p>
+          <a:p>
+            <a:pPr>
+              <a:defRPr sz="1200" i="1"/>
+            </a:pPr>
+            <a:r>
+              <a:t>DECISION · Whole dept at decision year · HERO peer-context X</a:t>
+            </a:r>
+          </a:p>
+        </p:txBody>
+      </p:sp>
+      <p:sp>
+        <p:nvSpPr>
+          <p:cNvPr id="3" name="TextBox 2"/>
+          <p:cNvSpPr txBox="1"/>
+          <p:nvPr/>
+        </p:nvSpPr>
+        <p:spPr>
+          <a:xfrm>
+            <a:off x="411480" y="777240"/>
+            <a:ext cx="11368735" cy="713232"/>
+          </a:xfrm>
+          <a:prstGeom prst="rect">
+            <a:avLst/>
+          </a:prstGeom>
+          <a:noFill/>
+        </p:spPr>
+        <p:txBody>
+          <a:bodyPr wrap="square">
+            <a:spAutoFit/>
+          </a:bodyPr>
+          <a:lstStyle/>
+          <a:p>
+            <a:pPr>
+              <a:spcAft>
+                <a:spcPts val="200"/>
+              </a:spcAft>
+              <a:defRPr sz="1100"/>
+            </a:pPr>
+            <a:r>
+              <a:t>• LOO mean of all other faculty's pubs_per_career_year in department.</a:t>
+            </a:r>
+          </a:p>
+          <a:p>
+            <a:pPr>
+              <a:spcAft>
+                <a:spcPts val="200"/>
+              </a:spcAft>
+              <a:defRPr sz="1100"/>
+            </a:pPr>
+            <a:r>
+              <a:t>• 389/391 with computable dept LOO — primary HERO x-axis.</a:t>
+            </a:r>
+          </a:p>
+          <a:p>
+            <a:pPr>
+              <a:spcAft>
+                <a:spcPts val="200"/>
+              </a:spcAft>
+              <a:defRPr sz="1100"/>
+            </a:pPr>
+            <a:r>
+              <a:t>• Includes senior faculty, not assistant-only uni×year pool.</a:t>
+            </a:r>
+          </a:p>
+        </p:txBody>
+      </p:sp>
+      <p:pic>
+        <p:nvPicPr>
+          <p:cNvPr id="4" name="Picture 3" descr="TENURE_dept_loo_career_rate_pd29.png"/>
+          <p:cNvPicPr>
+            <a:picLocks noChangeAspect="1"/>
+          </p:cNvPicPr>
+          <p:nvPr/>
+        </p:nvPicPr>
+        <p:blipFill>
+          <a:blip r:embed="rId2"/>
+          <a:stretch>
+            <a:fillRect/>
+          </a:stretch>
+        </p:blipFill>
+        <p:spPr>
+          <a:xfrm>
+            <a:off x="2967227" y="1545336"/>
+            <a:ext cx="6257240" cy="3877056"/>
+          </a:xfrm>
+          <a:prstGeom prst="rect">
+            <a:avLst/>
+          </a:prstGeom>
+        </p:spPr>
+      </p:pic>
+      <p:sp>
+        <p:nvSpPr>
+          <p:cNvPr id="5" name="TextBox 4"/>
+          <p:cNvSpPr txBox="1"/>
+          <p:nvPr/>
+        </p:nvSpPr>
+        <p:spPr>
+          <a:xfrm>
+            <a:off x="411480" y="5495544"/>
+            <a:ext cx="11368735" cy="502920"/>
+          </a:xfrm>
+          <a:prstGeom prst="rect">
+            <a:avLst/>
+          </a:prstGeom>
+          <a:noFill/>
+        </p:spPr>
+        <p:txBody>
+          <a:bodyPr wrap="square" anchor="t">
+            <a:spAutoFit/>
+          </a:bodyPr>
+          <a:lstStyle/>
+          <a:p>
+            <a:pPr algn="l">
+              <a:defRPr sz="800">
+                <a:latin typeface="Menlo"/>
+              </a:defRPr>
+            </a:pPr>
+            <a:r>
+              <a:t>python tenure/scripts/tenure_basic_plots.py --mode pd29 --only dept_loo</a:t>
+            </a:r>
+          </a:p>
+        </p:txBody>
+      </p:sp>
+      <p:sp>
+        <p:nvSpPr>
+          <p:cNvPr id="6" name="TextBox 5"/>
+          <p:cNvSpPr txBox="1"/>
+          <p:nvPr/>
+        </p:nvSpPr>
+        <p:spPr>
+          <a:xfrm>
+            <a:off x="411480" y="6035040"/>
+            <a:ext cx="11368735" cy="384048"/>
+          </a:xfrm>
+          <a:prstGeom prst="rect">
+            <a:avLst/>
+          </a:prstGeom>
+          <a:noFill/>
+        </p:spPr>
+        <p:txBody>
+          <a:bodyPr wrap="square">
+            <a:spAutoFit/>
+          </a:bodyPr>
+          <a:lstStyle/>
+          <a:p>
+            <a:pPr>
+              <a:defRPr sz="1000"/>
+            </a:pPr>
+            <a:r>
+              <a:t>n=389 · med=4.69 · mean=4.76</a:t>
+            </a:r>
+          </a:p>
+        </p:txBody>
+      </p:sp>
+    </p:spTree>
+  </p:cSld>
+  <p:clrMapOvr>
+    <a:masterClrMapping/>
+  </p:clrMapOvr>
+</p:sld>
+</file>
+
+<file path=ppt/slides/slide15.xml><?xml version="1.0" encoding="utf-8"?>
+<p:sld xmlns:a="http://schemas.openxmlformats.org/drawingml/2006/main" xmlns:p="http://schemas.openxmlformats.org/presentationml/2006/main" xmlns:r="http://schemas.openxmlformats.org/officeDocument/2006/relationships">
+  <p:cSld>
+    <p:spTree>
+      <p:nvGrpSpPr>
+        <p:cNvPr id="1" name=""/>
+        <p:cNvGrpSpPr/>
+        <p:nvPr/>
+      </p:nvGrpSpPr>
+      <p:grpSpPr/>
+      <p:sp>
+        <p:nvSpPr>
+          <p:cNvPr id="2" name="TextBox 1"/>
+          <p:cNvSpPr txBox="1"/>
+          <p:nvPr/>
+        </p:nvSpPr>
+        <p:spPr>
+          <a:xfrm>
+            <a:off x="411480" y="201168"/>
+            <a:ext cx="11368735" cy="502920"/>
+          </a:xfrm>
+          <a:prstGeom prst="rect">
+            <a:avLst/>
+          </a:prstGeom>
+          <a:noFill/>
+        </p:spPr>
+        <p:txBody>
+          <a:bodyPr wrap="square">
+            <a:spAutoFit/>
+          </a:bodyPr>
+          <a:lstStyle/>
+          <a:p>
+            <a:pPr>
+              <a:defRPr b="1" sz="2000"/>
+            </a:pPr>
+            <a:r>
+              <a:t>Slide 13 — Dept pond LOO by outcome</a:t>
+            </a:r>
+          </a:p>
+          <a:p>
+            <a:pPr>
+              <a:defRPr sz="1200" i="1"/>
+            </a:pPr>
+            <a:r>
+              <a:t>DECISION · Peer environment split · complements decision HERO</a:t>
+            </a:r>
+          </a:p>
+        </p:txBody>
+      </p:sp>
+      <p:sp>
+        <p:nvSpPr>
+          <p:cNvPr id="3" name="TextBox 2"/>
+          <p:cNvSpPr txBox="1"/>
+          <p:nvPr/>
+        </p:nvSpPr>
+        <p:spPr>
+          <a:xfrm>
+            <a:off x="411480" y="777240"/>
+            <a:ext cx="11368735" cy="713232"/>
+          </a:xfrm>
+          <a:prstGeom prst="rect">
+            <a:avLst/>
+          </a:prstGeom>
+          <a:noFill/>
+        </p:spPr>
+        <p:txBody>
+          <a:bodyPr wrap="square">
+            <a:spAutoFit/>
+          </a:bodyPr>
+          <a:lstStyle/>
+          <a:p>
+            <a:pPr>
+              <a:spcAft>
+                <a:spcPts val="200"/>
+              </a:spcAft>
+              <a:defRPr sz="1100"/>
+            </a:pPr>
+            <a:r>
+              <a:t>• Marginal dept LOO by tenure vs attrition — not binned rates.</a:t>
+            </a:r>
+          </a:p>
+          <a:p>
+            <a:pPr>
+              <a:spcAft>
+                <a:spcPts val="200"/>
+              </a:spcAft>
+              <a:defRPr sz="1100"/>
+            </a:pPr>
+            <a:r>
+              <a:t>• Ask: did promoted faculty sit in stronger department ponds on average?</a:t>
+            </a:r>
+          </a:p>
+        </p:txBody>
+      </p:sp>
+      <p:pic>
+        <p:nvPicPr>
+          <p:cNvPr id="4" name="Picture 3" descr="TENURE_dept_loo_career_rate_by_outcome_pd29.png"/>
+          <p:cNvPicPr>
+            <a:picLocks noChangeAspect="1"/>
+          </p:cNvPicPr>
+          <p:nvPr/>
+        </p:nvPicPr>
+        <p:blipFill>
+          <a:blip r:embed="rId2"/>
+          <a:stretch>
+            <a:fillRect/>
+          </a:stretch>
+        </p:blipFill>
+        <p:spPr>
+          <a:xfrm>
+            <a:off x="2932854" y="1545336"/>
+            <a:ext cx="6325987" cy="3877056"/>
+          </a:xfrm>
+          <a:prstGeom prst="rect">
+            <a:avLst/>
+          </a:prstGeom>
+        </p:spPr>
+      </p:pic>
+      <p:sp>
+        <p:nvSpPr>
+          <p:cNvPr id="5" name="TextBox 4"/>
+          <p:cNvSpPr txBox="1"/>
+          <p:nvPr/>
+        </p:nvSpPr>
+        <p:spPr>
+          <a:xfrm>
+            <a:off x="411480" y="5495544"/>
+            <a:ext cx="11368735" cy="502920"/>
+          </a:xfrm>
+          <a:prstGeom prst="rect">
+            <a:avLst/>
+          </a:prstGeom>
+          <a:noFill/>
+        </p:spPr>
+        <p:txBody>
+          <a:bodyPr wrap="square" anchor="t">
+            <a:spAutoFit/>
+          </a:bodyPr>
+          <a:lstStyle/>
+          <a:p>
+            <a:pPr algn="l">
+              <a:defRPr sz="800">
+                <a:latin typeface="Menlo"/>
+              </a:defRPr>
+            </a:pPr>
+            <a:r>
+              <a:t>python tenure/scripts/tenure_basic_plots.py --mode pd29 --only dept_loo_by_outcome</a:t>
+            </a:r>
+          </a:p>
+        </p:txBody>
+      </p:sp>
+      <p:sp>
+        <p:nvSpPr>
+          <p:cNvPr id="6" name="TextBox 5"/>
+          <p:cNvSpPr txBox="1"/>
+          <p:nvPr/>
+        </p:nvSpPr>
+        <p:spPr>
+          <a:xfrm>
+            <a:off x="411480" y="6035040"/>
+            <a:ext cx="11368735" cy="384048"/>
+          </a:xfrm>
+          <a:prstGeom prst="rect">
+            <a:avLst/>
+          </a:prstGeom>
+          <a:noFill/>
+        </p:spPr>
+        <p:txBody>
+          <a:bodyPr wrap="square">
+            <a:spAutoFit/>
+          </a:bodyPr>
+          <a:lstStyle/>
+          <a:p>
+            <a:pPr>
+              <a:defRPr sz="1000"/>
+            </a:pPr>
+            <a:r>
+              <a:t>tenured n=191 med=4.7 · attrition n=198 med=4.8</a:t>
+            </a:r>
+          </a:p>
+        </p:txBody>
+      </p:sp>
+    </p:spTree>
+  </p:cSld>
+  <p:clrMapOvr>
+    <a:masterClrMapping/>
+  </p:clrMapOvr>
+</p:sld>
+</file>
+
+<file path=ppt/slides/slide16.xml><?xml version="1.0" encoding="utf-8"?>
+<p:sld xmlns:a="http://schemas.openxmlformats.org/drawingml/2006/main" xmlns:p="http://schemas.openxmlformats.org/presentationml/2006/main" xmlns:r="http://schemas.openxmlformats.org/officeDocument/2006/relationships">
+  <p:cSld>
+    <p:spTree>
+      <p:nvGrpSpPr>
+        <p:cNvPr id="1" name=""/>
+        <p:cNvGrpSpPr/>
+        <p:nvPr/>
+      </p:nvGrpSpPr>
+      <p:grpSpPr/>
+      <p:sp>
+        <p:nvSpPr>
+          <p:cNvPr id="2" name="TextBox 1"/>
+          <p:cNvSpPr txBox="1"/>
+          <p:nvPr/>
+        </p:nvSpPr>
+        <p:spPr>
+          <a:xfrm>
+            <a:off x="411480" y="201168"/>
+            <a:ext cx="11368735" cy="502920"/>
+          </a:xfrm>
+          <a:prstGeom prst="rect">
+            <a:avLst/>
+          </a:prstGeom>
+          <a:noFill/>
+        </p:spPr>
+        <p:txBody>
+          <a:bodyPr wrap="square">
+            <a:spAutoFit/>
+          </a:bodyPr>
+          <a:lstStyle/>
+          <a:p>
+            <a:pPr>
+              <a:defRPr b="1" sz="2000"/>
+            </a:pPr>
+            <a:r>
+              <a:t>Slide 14 — Zero annual pubs but positive career rate (tenured)</a:t>
+            </a:r>
+          </a:p>
+          <a:p>
+            <a:pPr>
+              <a:defRPr sz="1200" i="1"/>
+            </a:pPr>
+            <a:r>
+              <a:t>DECISION · Wrong lens if you use pubs_year only</a:t>
+            </a:r>
+          </a:p>
+        </p:txBody>
+      </p:sp>
+      <p:sp>
+        <p:nvSpPr>
+          <p:cNvPr id="3" name="TextBox 2"/>
+          <p:cNvSpPr txBox="1"/>
+          <p:nvPr/>
+        </p:nvSpPr>
+        <p:spPr>
+          <a:xfrm>
+            <a:off x="411480" y="777240"/>
+            <a:ext cx="11368735" cy="713232"/>
+          </a:xfrm>
+          <a:prstGeom prst="rect">
+            <a:avLst/>
+          </a:prstGeom>
+          <a:noFill/>
+        </p:spPr>
+        <p:txBody>
+          <a:bodyPr wrap="square">
+            <a:spAutoFit/>
+          </a:bodyPr>
+          <a:lstStyle/>
+          <a:p>
+            <a:pPr>
+              <a:spcAft>
+                <a:spcPts val="200"/>
+              </a:spcAft>
+              <a:defRPr sz="1100"/>
+            </a:pPr>
+            <a:r>
+              <a:t>• Tenured with pubs_year=0 at decision but pubs_per_career_year &gt; 0.</a:t>
+            </a:r>
+          </a:p>
+          <a:p>
+            <a:pPr>
+              <a:spcAft>
+                <a:spcPts val="200"/>
+              </a:spcAft>
+              <a:defRPr sz="1100"/>
+            </a:pPr>
+            <a:r>
+              <a:t>• Motivates cumulative / career-rate lock vs single-year annual count.</a:t>
+            </a:r>
+          </a:p>
+        </p:txBody>
+      </p:sp>
+      <p:pic>
+        <p:nvPicPr>
+          <p:cNvPr id="4" name="Picture 3" descr="TENURE_annual_zero_tenured_pd29.png"/>
+          <p:cNvPicPr>
+            <a:picLocks noChangeAspect="1"/>
+          </p:cNvPicPr>
+          <p:nvPr/>
+        </p:nvPicPr>
+        <p:blipFill>
+          <a:blip r:embed="rId2"/>
+          <a:stretch>
+            <a:fillRect/>
+          </a:stretch>
+        </p:blipFill>
+        <p:spPr>
+          <a:xfrm>
+            <a:off x="2831578" y="1545336"/>
+            <a:ext cx="6528538" cy="3877056"/>
+          </a:xfrm>
+          <a:prstGeom prst="rect">
+            <a:avLst/>
+          </a:prstGeom>
+        </p:spPr>
+      </p:pic>
+      <p:sp>
+        <p:nvSpPr>
+          <p:cNvPr id="5" name="TextBox 4"/>
+          <p:cNvSpPr txBox="1"/>
+          <p:nvPr/>
+        </p:nvSpPr>
+        <p:spPr>
+          <a:xfrm>
+            <a:off x="411480" y="5495544"/>
+            <a:ext cx="11368735" cy="502920"/>
+          </a:xfrm>
+          <a:prstGeom prst="rect">
+            <a:avLst/>
+          </a:prstGeom>
+          <a:noFill/>
+        </p:spPr>
+        <p:txBody>
+          <a:bodyPr wrap="square" anchor="t">
+            <a:spAutoFit/>
+          </a:bodyPr>
+          <a:lstStyle/>
+          <a:p>
+            <a:pPr algn="l">
+              <a:defRPr sz="800">
+                <a:latin typeface="Menlo"/>
+              </a:defRPr>
+            </a:pPr>
+            <a:r>
+              <a:t>python tenure/scripts/tenure_basic_plots.py --mode pd29 --only annual_zero_tenured</a:t>
+            </a:r>
+          </a:p>
+        </p:txBody>
+      </p:sp>
+      <p:sp>
+        <p:nvSpPr>
+          <p:cNvPr id="6" name="TextBox 5"/>
+          <p:cNvSpPr txBox="1"/>
+          <p:nvPr/>
+        </p:nvSpPr>
+        <p:spPr>
+          <a:xfrm>
+            <a:off x="411480" y="6035040"/>
+            <a:ext cx="11368735" cy="384048"/>
+          </a:xfrm>
+          <a:prstGeom prst="rect">
+            <a:avLst/>
+          </a:prstGeom>
+          <a:noFill/>
+        </p:spPr>
+        <p:txBody>
+          <a:bodyPr wrap="square">
+            <a:spAutoFit/>
+          </a:bodyPr>
+          <a:lstStyle/>
+          <a:p>
+            <a:pPr>
+              <a:defRPr sz="1000"/>
+            </a:pPr>
+            <a:r>
+              <a:t>tenured=191 · zero annual / +career=6 (3.14%)</a:t>
             </a:r>
           </a:p>
         </p:txBody>
@@ -3280,7 +4584,7 @@
               <a:defRPr sz="1200" i="1"/>
             </a:pPr>
             <a:r>
-              <a:t>MBB PD17 / reigning overlap analog · pubs_year z within year</a:t>
+              <a:t>ASST-PS · MBB PD17 / reigning overlap analog · pubs_year z within year</a:t>
             </a:r>
           </a:p>
         </p:txBody>
@@ -3424,7 +4728,7 @@
               <a:defRPr sz="1000"/>
             </a:pPr>
             <a:r>
-              <a:t>uni-year pools=283 · asst-years=2,396 · max coverage=245 · H_sort=0.173</a:t>
+              <a:t>uni-year pools=283 · asst-years=2,373 · max coverage=243 · H_sort=0.174</a:t>
             </a:r>
           </a:p>
         </p:txBody>
@@ -3481,7 +4785,7 @@
               <a:defRPr sz="1200" i="1"/>
             </a:pPr>
             <a:r>
-              <a:t>Sensitivity — intensive margin only · compare to prior slide</a:t>
+              <a:t>ASST-PS · Sensitivity — intensive margin only · compare to prior slide</a:t>
             </a:r>
           </a:p>
         </p:txBody>
@@ -3625,7 +4929,7 @@
               <a:defRPr sz="1000"/>
             </a:pPr>
             <a:r>
-              <a:t>uni-year pools=263 · asst-years=1,544 · max coverage=208 · H_sort=0.204</a:t>
+              <a:t>uni-year pools=263 · asst-years=1,526 · max coverage=205 · H_sort=0.207</a:t>
             </a:r>
           </a:p>
         </p:txBody>
@@ -3682,7 +4986,7 @@
               <a:defRPr sz="1200" i="1"/>
             </a:pPr>
             <a:r>
-              <a:t>Person-level mean · N≈796 matches Q16/Q20 HERO</a:t>
+              <a:t>ASST-PS · Person-level mean · N≈796 matches Q16/Q20 HERO</a:t>
             </a:r>
           </a:p>
         </p:txBody>
@@ -3815,7 +5119,7 @@
               <a:defRPr sz="1000"/>
             </a:pPr>
             <a:r>
-              <a:t>n=796 · median=3.35 · mean=4.24 · sd=3.16</a:t>
+              <a:t>n=787 · median=3.34 · mean=4.22 · sd=3.16</a:t>
             </a:r>
           </a:p>
         </p:txBody>
@@ -3872,7 +5176,7 @@
               <a:defRPr sz="1200" i="1"/>
             </a:pPr>
             <a:r>
-              <a:t>Unconditional + inset (pubs &gt; 0) · inference panel</a:t>
+              <a:t>ASST-PS · Unconditional + inset (pubs &gt; 0) · inference panel</a:t>
             </a:r>
           </a:p>
         </p:txBody>
@@ -4016,7 +5320,7 @@
               <a:defRPr sz="1000"/>
             </a:pPr>
             <a:r>
-              <a:t>all n=2,396 (36% zero) · inset n=1,544 · med=7.0 · mean=9.7</a:t>
+              <a:t>all n=2,373 (36% zero) · inset n=1,526 · med=7.0 · mean=9.7</a:t>
             </a:r>
           </a:p>
         </p:txBody>
@@ -4073,7 +5377,7 @@
               <a:defRPr sz="1200" i="1"/>
             </a:pPr>
             <a:r>
-              <a:t>pool_size_oa_loo on assistant person-years</a:t>
+              <a:t>ASST-PS · pool_size_oa_loo on assistant person-years</a:t>
             </a:r>
           </a:p>
         </p:txBody>
@@ -4206,7 +5510,7 @@
               <a:defRPr sz="1000"/>
             </a:pPr>
             <a:r>
-              <a:t>n=2,396 · median=15.00 · mean=17.22 · sd=10.32</a:t>
+              <a:t>n=2,373 · median=15.00 · mean=17.12 · sd=10.36</a:t>
             </a:r>
           </a:p>
         </p:txBody>
@@ -4263,7 +5567,7 @@
               <a:defRPr sz="1200" i="1"/>
             </a:pPr>
             <a:r>
-              <a:t>Tenured vs attrition vs censored · same HERO N</a:t>
+              <a:t>ASST-PS · Tenured vs attrition vs censored · same HERO N</a:t>
             </a:r>
           </a:p>
         </p:txBody>
@@ -4340,8 +5644,8 @@
         </p:blipFill>
         <p:spPr>
           <a:xfrm>
-            <a:off x="2935368" y="1545336"/>
-            <a:ext cx="6320958" cy="3877056"/>
+            <a:off x="2932854" y="1545336"/>
+            <a:ext cx="6325987" cy="3877056"/>
           </a:xfrm>
           <a:prstGeom prst="rect">
             <a:avLst/>
@@ -4407,7 +5711,7 @@
               <a:defRPr sz="1000"/>
             </a:pPr>
             <a:r>
-              <a:t>tenured n=174 med=6.2 · attrition n=202 med=3.0 · censored n=420 med=2.0</a:t>
+              <a:t>tenured n=191 med=6.0 · attrition n=194 med=2.8 · censored n=402 med=1.7</a:t>
             </a:r>
           </a:p>
         </p:txBody>
@@ -4464,7 +5768,7 @@
               <a:defRPr sz="1200" i="1"/>
             </a:pPr>
             <a:r>
-              <a:t>Tenured only · person-level mean + inset (mean &gt; 0)</a:t>
+              <a:t>ASST-PS · Tenured only · person-level mean + inset (mean &gt; 0)</a:t>
             </a:r>
           </a:p>
         </p:txBody>
@@ -4541,8 +5845,8 @@
         </p:blipFill>
         <p:spPr>
           <a:xfrm>
-            <a:off x="2932854" y="1545336"/>
-            <a:ext cx="6325987" cy="3877056"/>
+            <a:off x="2935368" y="1545336"/>
+            <a:ext cx="6320958" cy="3877056"/>
           </a:xfrm>
           <a:prstGeom prst="rect">
             <a:avLst/>
@@ -4608,7 +5912,7 @@
               <a:defRPr sz="1000"/>
             </a:pPr>
             <a:r>
-              <a:t>tenured n=174 · med=6.2 · mean=7.7 · inset n=133</a:t>
+              <a:t>tenured n=191 · med=6.0 · mean=7.7 · inset n=149</a:t>
             </a:r>
           </a:p>
         </p:txBody>
@@ -4665,7 +5969,7 @@
               <a:defRPr sz="1200" i="1"/>
             </a:pPr>
             <a:r>
-              <a:t>Peer environment split · complements HERO x-axis</a:t>
+              <a:t>ASST-PS · Peer environment split · complements HERO x-axis</a:t>
             </a:r>
           </a:p>
         </p:txBody>
@@ -4809,7 +6113,7 @@
               <a:defRPr sz="1000"/>
             </a:pPr>
             <a:r>
-              <a:t>tenured n=174 med=3.8 · attrition n=202 med=3.5 · censored n=420 med=3.2</a:t>
+              <a:t>tenured n=191 med=3.8 · attrition n=194 med=3.7 · censored n=402 med=3.1</a:t>
             </a:r>
           </a:p>
         </p:txBody>

</xml_diff>